<commit_message>
Link official deck to demo video
</commit_message>
<xml_diff>
--- a/SignalLedger-Official-Submission-Template.pptx
+++ b/SignalLedger-Official-Submission-Template.pptx
@@ -10062,7 +10062,7 @@
                 </a:solidFill>
                 <a:latin typeface="Google Sans Flex"/>
               </a:rPr>
-              <a:t>All core links are live. Add the final video URL after recording.</a:t>
+              <a:t>All core links are live, including the subtitled demo video.</a:t>
             </a:r>
           </a:p>
         </p:txBody>
@@ -10452,7 +10452,7 @@
                 </a:solidFill>
                 <a:latin typeface="Google Sans Flex"/>
               </a:rPr>
-              <a:t>[ADD FINAL VIDEO LINK]</a:t>
+              <a:t>https://raw.githubusercontent.com/vzzzzzzz17/signalledger-ai-builder-cup-2026/main/SignalLedger-Demo-Video.mp4</a:t>
             </a:r>
           </a:p>
         </p:txBody>

</xml_diff>

<commit_message>
Correct team names in demo and submission deck
</commit_message>
<xml_diff>
--- a/SignalLedger-Official-Submission-Template.pptx
+++ b/SignalLedger-Official-Submission-Template.pptx
@@ -6738,7 +6738,7 @@
               <a:rPr sz="1400" b="0">
                 <a:latin typeface="Google Sans Flex"/>
               </a:rPr>
-              <a:t>Team leader name: Zhngwei</a:t>
+              <a:t>Team leader name: Zhangwei</a:t>
             </a:r>
           </a:p>
           <a:p>
@@ -6751,7 +6751,7 @@
               <a:rPr sz="1400" b="0">
                 <a:latin typeface="Google Sans Flex"/>
               </a:rPr>
-              <a:t>Team member: Jiaoyi Chen</a:t>
+              <a:t>Team member: Chen Jiaoyi</a:t>
             </a:r>
           </a:p>
           <a:p>

</xml_diff>

<commit_message>
Verify and document live Vertex AI Gemini integration
</commit_message>
<xml_diff>
--- a/SignalLedger-Official-Submission-Template.pptx
+++ b/SignalLedger-Official-Submission-Template.pptx
@@ -16751,16 +16751,13 @@
           </a:bodyPr>
           <a:lstStyle/>
           <a:p>
-            <a:pPr algn="ctr"/>
-            <a:r>
-              <a:rPr sz="950" b="0">
-                <a:solidFill>
-                  <a:srgbClr val="667085"/>
-                </a:solidFill>
-                <a:latin typeface="Google Sans Flex"/>
-              </a:rPr>
-              <a:t>Opt-in extraction
-not default</a:t>
+            <a:r>
+              <a:t>Live text extraction</a:t>
+            </a:r>
+          </a:p>
+          <a:p>
+            <a:r>
+              <a:t>on Analyze</a:t>
             </a:r>
           </a:p>
         </p:txBody>
@@ -16980,7 +16977,7 @@
                 </a:solidFill>
                 <a:latin typeface="Google Sans Flex"/>
               </a:rPr>
-              <a:t>Default public deployment disables live model calls to keep the Demo within zero-model-cost mode.</a:t>
+              <a:t>Public Demo calls Gemini only after an explicit Analyze action; no automatic model calls on feed load.</a:t>
             </a:r>
           </a:p>
         </p:txBody>
@@ -17673,7 +17670,7 @@
                 <a:latin typeface="Google Sans Flex"/>
               </a:rPr>
               <a:t>Gemini / Vertex AI
-Structured JSON extraction</a:t>
+Gemini 2.5 Flash structured extraction</a:t>
             </a:r>
           </a:p>
         </p:txBody>
@@ -17906,15 +17903,8 @@
           </a:bodyPr>
           <a:lstStyle/>
           <a:p>
-            <a:pPr algn="ctr"/>
-            <a:r>
-              <a:rPr sz="1200" b="1">
-                <a:solidFill>
-                  <a:srgbClr val="0F766E"/>
-                </a:solidFill>
-                <a:latin typeface="Google Sans Flex"/>
-              </a:rPr>
-              <a:t>Google Cloud services are used for deployment, API isolation, caching, and the opt-in AI path.</a:t>
+            <a:r>
+              <a:t>Google Cloud services are used for deployment, API isolation, caching, and the live Gemini path.</a:t>
             </a:r>
           </a:p>
         </p:txBody>
@@ -18116,15 +18106,8 @@
           </a:bodyPr>
           <a:lstStyle/>
           <a:p>
-            <a:pPr algn="l"/>
-            <a:r>
-              <a:rPr sz="950" b="0">
-                <a:solidFill>
-                  <a:srgbClr val="667085"/>
-                </a:solidFill>
-                <a:latin typeface="Google Sans Flex"/>
-              </a:rPr>
-              <a:t>A cost-safe public Demo with a clear switch for live model usage.</a:t>
+            <a:r>
+              <a:t>A controlled public Demo with explicit Gemini analysis actions.</a:t>
             </a:r>
           </a:p>
         </p:txBody>
@@ -18596,16 +18579,13 @@
           </a:bodyPr>
           <a:lstStyle/>
           <a:p>
-            <a:pPr algn="l"/>
-            <a:r>
-              <a:rPr sz="950" b="0">
-                <a:solidFill>
-                  <a:srgbClr val="111827"/>
-                </a:solidFill>
-                <a:latin typeface="Google Sans Flex"/>
-              </a:rPr>
-              <a:t>Firebase + Cloud Run min 0
-Offline context</a:t>
+            <a:r>
+              <a:t>Firebase + Cloud Run + Vertex AI</a:t>
+            </a:r>
+          </a:p>
+          <a:p>
+            <a:r>
+              <a:t>Explicit Analyze action</a:t>
             </a:r>
           </a:p>
         </p:txBody>
@@ -18677,15 +18657,8 @@
           </a:bodyPr>
           <a:lstStyle/>
           <a:p>
-            <a:pPr algn="l"/>
-            <a:r>
-              <a:rPr sz="950" b="0">
-                <a:solidFill>
-                  <a:srgbClr val="111827"/>
-                </a:solidFill>
-                <a:latin typeface="Google Sans Flex"/>
-              </a:rPr>
-              <a:t>Designed for free usage</a:t>
+            <a:r>
+              <a:t>Usage-based; user-triggered</a:t>
             </a:r>
           </a:p>
         </p:txBody>
@@ -18917,15 +18890,8 @@
           </a:bodyPr>
           <a:lstStyle/>
           <a:p>
-            <a:pPr algn="l"/>
-            <a:r>
-              <a:rPr sz="950" b="0">
-                <a:solidFill>
-                  <a:srgbClr val="111827"/>
-                </a:solidFill>
-                <a:latin typeface="Google Sans Flex"/>
-              </a:rPr>
-              <a:t>Vertex AI Gemini extraction</a:t>
+            <a:r>
+              <a:t>Vertex AI Gemini 2.5 Flash</a:t>
             </a:r>
           </a:p>
         </p:txBody>
@@ -18997,15 +18963,8 @@
           </a:bodyPr>
           <a:lstStyle/>
           <a:p>
-            <a:pPr algn="l"/>
-            <a:r>
-              <a:rPr sz="950" b="0">
-                <a:solidFill>
-                  <a:srgbClr val="111827"/>
-                </a:solidFill>
-                <a:latin typeface="Google Sans Flex"/>
-              </a:rPr>
-              <a:t>Usage-based; opt-in</a:t>
+            <a:r>
+              <a:t>Usage-based; user-triggered</a:t>
             </a:r>
           </a:p>
         </p:txBody>
@@ -19077,15 +19036,8 @@
           </a:bodyPr>
           <a:lstStyle/>
           <a:p>
-            <a:pPr algn="l"/>
-            <a:r>
-              <a:rPr sz="950" b="1">
-                <a:solidFill>
-                  <a:srgbClr val="0F766E"/>
-                </a:solidFill>
-                <a:latin typeface="Google Sans Flex"/>
-              </a:rPr>
-              <a:t>READY</a:t>
+            <a:r>
+              <a:t>DEPLOYED</a:t>
             </a:r>
           </a:p>
         </p:txBody>
@@ -19433,15 +19385,8 @@
           </a:bodyPr>
           <a:lstStyle/>
           <a:p>
-            <a:pPr algn="ctr"/>
-            <a:r>
-              <a:rPr sz="1100" b="0">
-                <a:solidFill>
-                  <a:srgbClr val="667085"/>
-                </a:solidFill>
-                <a:latin typeface="Google Sans Flex"/>
-              </a:rPr>
-              <a:t>No private data, no paid market-data key, and no live model call in the public default mode.</a:t>
+            <a:r>
+              <a:t>No private data; model calls occur only after an explicit Analyze action.</a:t>
             </a:r>
           </a:p>
         </p:txBody>

</xml_diff>

<commit_message>
Serve full prototype from Cloud Run
</commit_message>
<xml_diff>
--- a/SignalLedger-Official-Submission-Template.pptx
+++ b/SignalLedger-Official-Submission-Template.pptx
@@ -7944,15 +7944,8 @@
           </a:bodyPr>
           <a:lstStyle/>
           <a:p>
-            <a:pPr algn="ctr"/>
-            <a:r>
-              <a:rPr sz="1050" b="1">
-                <a:solidFill>
-                  <a:srgbClr val="2454A6"/>
-                </a:solidFill>
-                <a:latin typeface="Google Sans Flex"/>
-              </a:rPr>
-              <a:t>Live link: https://signalledger-ai-builder-cup.web.app</a:t>
+            <a:r>
+              <a:t>Cloud Run prototype: https://signalledger-api-991291718418.us-central1.run.app</a:t>
             </a:r>
           </a:p>
         </p:txBody>
@@ -10639,15 +10632,8 @@
           </a:bodyPr>
           <a:lstStyle/>
           <a:p>
-            <a:pPr algn="l"/>
-            <a:r>
-              <a:rPr sz="1000" b="1">
-                <a:solidFill>
-                  <a:srgbClr val="0F766E"/>
-                </a:solidFill>
-                <a:latin typeface="Google Sans Flex"/>
-              </a:rPr>
-              <a:t>https://signalledger-ai-builder-cup.web.app</a:t>
+            <a:r>
+              <a:t>https://signalledger-api-991291718418.us-central1.run.app</a:t>
             </a:r>
           </a:p>
         </p:txBody>

</xml_diff>